<commit_message>
updated presentation and readme overview
</commit_message>
<xml_diff>
--- a/docs/VTU-QFF-HC-0140.pptx
+++ b/docs/VTU-QFF-HC-0140.pptx
@@ -16,6 +16,7 @@
     <p:sldId id="261" r:id="rId10"/>
     <p:sldId id="262" r:id="rId11"/>
     <p:sldId id="266" r:id="rId15"/>
+    <p:sldId id="267" r:id="rId16"/>
     <p:sldId id="263" r:id="rId12"/>
     <p:sldId id="264" r:id="rId13"/>
     <p:sldId id="265" r:id="rId14"/>
@@ -3710,6 +3711,550 @@
 
 <file path=ppt/slides/slide10.xml><?xml version="1.0" encoding="utf-8"?>
 <p:sld xmlns:a="http://schemas.openxmlformats.org/drawingml/2006/main" xmlns:r="http://schemas.openxmlformats.org/officeDocument/2006/relationships" xmlns:p="http://schemas.openxmlformats.org/presentationml/2006/main">
+  <p:cSld name="Slide 9">
+    <p:spTree>
+      <p:nvGrpSpPr>
+        <p:cNvPr id="1" name=""/>
+        <p:cNvGrpSpPr/>
+        <p:nvPr/>
+      </p:nvGrpSpPr>
+      <p:grpSpPr>
+        <a:xfrm>
+          <a:off x="0" y="0"/>
+          <a:ext cx="0" cy="0"/>
+          <a:chOff x="0" y="0"/>
+          <a:chExt cx="0" cy="0"/>
+        </a:xfrm>
+      </p:grpSpPr>
+      <p:sp>
+        <p:nvSpPr>
+          <p:cNvPr id="2" name="Text 14"/>
+          <p:cNvSpPr>
+            <a:spLocks noGrp="1"/>
+          </p:cNvSpPr>
+          <p:nvPr>
+            <p:ph type="title" idx="120" hasCustomPrompt="1"/>
+          </p:nvPr>
+        </p:nvSpPr>
+        <p:spPr>
+          <a:xfrm>
+            <a:off x="457200" y="841248"/>
+            <a:ext cx="6309360" cy="594360"/>
+          </a:xfrm>
+          <a:prstGeom prst="rect">
+            <a:avLst/>
+          </a:prstGeom>
+          <a:noFill/>
+          <a:ln/>
+        </p:spPr>
+        <p:txBody>
+          <a:bodyPr wrap="square" lIns="0" tIns="0" rIns="0" bIns="0" rtlCol="0" anchor="ctr"/>
+          <a:lstStyle/>
+          <a:p>
+            <a:pPr marL="0" indent="0" algn="l">
+              <a:buNone/>
+            </a:pPr>
+            <a:r>
+              <a:rPr lang="en-US" sz="2600" b="1" dirty="0">
+                <a:solidFill>
+                  <a:srgbClr val="2E1B5B"/>
+                </a:solidFill>
+                <a:latin typeface="Georgia" pitchFamily="34" charset="0"/>
+                <a:ea typeface="Georgia" pitchFamily="34" charset="-122"/>
+                <a:cs typeface="Georgia" pitchFamily="34" charset="-120"/>
+              </a:rPr>
+              <a:t>Challenges &amp; Future Scope</a:t>
+            </a:r>
+            <a:endParaRPr lang="en-US" sz="2600" dirty="0"/>
+          </a:p>
+        </p:txBody>
+      </p:sp>
+      <p:sp>
+        <p:nvSpPr>
+          <p:cNvPr id="3" name="Title accent"/>
+          <p:cNvSpPr/>
+          <p:nvPr/>
+        </p:nvSpPr>
+        <p:spPr>
+          <a:xfrm>
+            <a:off x="457200" y="1463040"/>
+            <a:ext cx="256032" cy="45720"/>
+          </a:xfrm>
+          <a:prstGeom prst="rect">
+            <a:avLst/>
+          </a:prstGeom>
+          <a:solidFill>
+            <a:srgbClr val="7C93F0"/>
+          </a:solidFill>
+          <a:ln w="12700">
+            <a:solidFill>
+              <a:srgbClr val="7C93F0"/>
+            </a:solidFill>
+            <a:prstDash val="solid"/>
+          </a:ln>
+        </p:spPr>
+      </p:sp>
+      <p:sp>
+        <p:nvSpPr>
+          <p:cNvPr id="4" name="Title accent"/>
+          <p:cNvSpPr/>
+          <p:nvPr/>
+        </p:nvSpPr>
+        <p:spPr>
+          <a:xfrm>
+            <a:off x="731520" y="1463040"/>
+            <a:ext cx="256032" cy="45720"/>
+          </a:xfrm>
+          <a:prstGeom prst="rect">
+            <a:avLst/>
+          </a:prstGeom>
+          <a:solidFill>
+            <a:srgbClr val="E8639F"/>
+          </a:solidFill>
+          <a:ln w="12700">
+            <a:solidFill>
+              <a:srgbClr val="E8639F"/>
+            </a:solidFill>
+            <a:prstDash val="solid"/>
+          </a:ln>
+        </p:spPr>
+      </p:sp>
+      <p:sp>
+        <p:nvSpPr>
+          <p:cNvPr id="5" name="Title accent"/>
+          <p:cNvSpPr/>
+          <p:nvPr/>
+        </p:nvSpPr>
+        <p:spPr>
+          <a:xfrm>
+            <a:off x="1005840" y="1463040"/>
+            <a:ext cx="256032" cy="45720"/>
+          </a:xfrm>
+          <a:prstGeom prst="rect">
+            <a:avLst/>
+          </a:prstGeom>
+          <a:solidFill>
+            <a:srgbClr val="5B3BA8"/>
+          </a:solidFill>
+          <a:ln w="12700">
+            <a:solidFill>
+              <a:srgbClr val="5B3BA8"/>
+            </a:solidFill>
+            <a:prstDash val="solid"/>
+          </a:ln>
+        </p:spPr>
+      </p:sp>
+      <p:sp>
+        <p:nvSpPr>
+          <p:cNvPr id="6" name="Content card"/>
+          <p:cNvSpPr/>
+          <p:nvPr/>
+        </p:nvSpPr>
+        <p:spPr>
+          <a:xfrm>
+            <a:off x="457200" y="1691640"/>
+            <a:ext cx="8229600" cy="2926080"/>
+          </a:xfrm>
+          <a:prstGeom prst="roundRect">
+            <a:avLst>
+              <a:gd name="adj" fmla="val 2500"/>
+            </a:avLst>
+          </a:prstGeom>
+          <a:solidFill>
+            <a:srgbClr val="FFFFFF"/>
+          </a:solidFill>
+          <a:ln w="9525">
+            <a:solidFill>
+              <a:srgbClr val="B8BDEB"/>
+            </a:solidFill>
+            <a:prstDash val="solid"/>
+          </a:ln>
+        </p:spPr>
+      </p:sp>
+      <p:sp>
+        <p:nvSpPr>
+          <p:cNvPr id="7" name="Card accent"/>
+          <p:cNvSpPr/>
+          <p:nvPr/>
+        </p:nvSpPr>
+        <p:spPr>
+          <a:xfrm>
+            <a:off x="685800" y="1691640"/>
+            <a:ext cx="822960" cy="54864"/>
+          </a:xfrm>
+          <a:prstGeom prst="rect">
+            <a:avLst/>
+          </a:prstGeom>
+          <a:solidFill>
+            <a:srgbClr val="E8639F"/>
+          </a:solidFill>
+          <a:ln w="12700">
+            <a:solidFill>
+              <a:srgbClr val="E8639F"/>
+            </a:solidFill>
+            <a:prstDash val="solid"/>
+          </a:ln>
+        </p:spPr>
+      </p:sp>
+      <p:sp>
+        <p:nvSpPr>
+          <p:cNvPr id="143" name="Challenges"/>
+          <p:cNvSpPr txBox="1"/>
+          <p:nvPr/>
+        </p:nvSpPr>
+        <p:spPr>
+          <a:xfrm>
+            <a:off x="685800" y="1828800"/>
+            <a:ext cx="4023360" cy="2697480"/>
+          </a:xfrm>
+          <a:prstGeom prst="rect">
+            <a:avLst/>
+          </a:prstGeom>
+          <a:noFill/>
+          <a:ln>
+            <a:noFill/>
+          </a:ln>
+        </p:spPr>
+        <p:txBody>
+          <a:bodyPr wrap="square" lIns="0" tIns="0" rIns="0" bIns="0" rtlCol="0" anchor="t">
+            <a:normAutofit/>
+          </a:bodyPr>
+          <a:lstStyle/>
+          <a:p>
+            <a:pPr marL="0" indent="0" algn="l">
+              <a:spcAft>
+                <a:spcPts val="400"/>
+              </a:spcAft>
+              <a:buNone/>
+            </a:pPr>
+            <a:r>
+              <a:rPr lang="en-US" sz="1200" b="1" dirty="0">
+                <a:solidFill>
+                  <a:srgbClr val="5B3BA8"/>
+                </a:solidFill>
+                <a:latin typeface="Calibri"/>
+                <a:cs typeface="Calibri"/>
+              </a:rPr>
+              <a:t xml:space="preserve">CHALLENGES WE HIT</a:t>
+            </a:r>
+          </a:p>
+          <a:p>
+            <a:pPr marL="171450" indent="-171450" algn="l">
+              <a:spcAft>
+                <a:spcPts val="400"/>
+              </a:spcAft>
+              <a:buClr>
+                <a:srgbClr val="5B3BA8"/>
+              </a:buClr>
+              <a:buFont typeface="Arial"/>
+              <a:buChar char="•"/>
+            </a:pPr>
+            <a:r>
+              <a:rPr lang="en-US" sz="1050" b="1" dirty="0">
+                <a:solidFill>
+                  <a:srgbClr val="2E1B5B"/>
+                </a:solidFill>
+                <a:latin typeface="Calibri"/>
+                <a:cs typeface="Calibri"/>
+              </a:rPr>
+              <a:t xml:space="preserve">Kernel concentration: </a:t>
+            </a:r>
+            <a:r>
+              <a:rPr lang="en-US" sz="1050" dirty="0">
+                <a:solidFill>
+                  <a:srgbClr val="2E1B5B"/>
+                </a:solidFill>
+                <a:latin typeface="Calibri"/>
+                <a:cs typeface="Calibri"/>
+              </a:rPr>
+              <a:t xml:space="preserve">spread fell 11× from 4 to 14 qubits; fixed with a bandwidth tuned by kernel-target alignment.</a:t>
+            </a:r>
+          </a:p>
+          <a:p>
+            <a:pPr marL="171450" indent="-171450" algn="l">
+              <a:spcAft>
+                <a:spcPts val="400"/>
+              </a:spcAft>
+              <a:buClr>
+                <a:srgbClr val="5B3BA8"/>
+              </a:buClr>
+              <a:buFont typeface="Arial"/>
+              <a:buChar char="•"/>
+            </a:pPr>
+            <a:r>
+              <a:rPr lang="en-US" sz="1050" b="1" dirty="0">
+                <a:solidFill>
+                  <a:srgbClr val="2E1B5B"/>
+                </a:solidFill>
+                <a:latin typeface="Calibri"/>
+                <a:cs typeface="Calibri"/>
+              </a:rPr>
+              <a:t xml:space="preserve">Split noise: </a:t>
+            </a:r>
+            <a:r>
+              <a:rPr lang="en-US" sz="1050" dirty="0">
+                <a:solidFill>
+                  <a:srgbClr val="2E1B5B"/>
+                </a:solidFill>
+                <a:latin typeface="Calibri"/>
+                <a:cs typeface="Calibri"/>
+              </a:rPr>
+              <a:t xml:space="preserve">one split flattered models by up to 0.04; we moved to 6 splits and paired tests.</a:t>
+            </a:r>
+          </a:p>
+          <a:p>
+            <a:pPr marL="171450" indent="-171450" algn="l">
+              <a:spcAft>
+                <a:spcPts val="400"/>
+              </a:spcAft>
+              <a:buClr>
+                <a:srgbClr val="5B3BA8"/>
+              </a:buClr>
+              <a:buFont typeface="Arial"/>
+              <a:buChar char="•"/>
+            </a:pPr>
+            <a:r>
+              <a:rPr lang="en-US" sz="1050" b="1" dirty="0">
+                <a:solidFill>
+                  <a:srgbClr val="2E1B5B"/>
+                </a:solidFill>
+                <a:latin typeface="Calibri"/>
+                <a:cs typeface="Calibri"/>
+              </a:rPr>
+              <a:t xml:space="preserve">Circuit cost: </a:t>
+            </a:r>
+            <a:r>
+              <a:rPr lang="en-US" sz="1050" dirty="0">
+                <a:solidFill>
+                  <a:srgbClr val="2E1B5B"/>
+                </a:solidFill>
+                <a:latin typeface="Calibri"/>
+                <a:cs typeface="Calibri"/>
+              </a:rPr>
+              <a:t xml:space="preserve">a full fidelity kernel needs 92.5 h on hardware; the projected kernel cuts it to 7.6 min.</a:t>
+            </a:r>
+          </a:p>
+          <a:p>
+            <a:pPr marL="171450" indent="-171450" algn="l">
+              <a:spcAft>
+                <a:spcPts val="400"/>
+              </a:spcAft>
+              <a:buClr>
+                <a:srgbClr val="5B3BA8"/>
+              </a:buClr>
+              <a:buFont typeface="Arial"/>
+              <a:buChar char="•"/>
+            </a:pPr>
+            <a:r>
+              <a:rPr lang="en-US" sz="1050" b="1" dirty="0">
+                <a:solidFill>
+                  <a:srgbClr val="2E1B5B"/>
+                </a:solidFill>
+                <a:latin typeface="Calibri"/>
+                <a:cs typeface="Calibri"/>
+              </a:rPr>
+              <a:t xml:space="preserve">Crashes on Linux: </a:t>
+            </a:r>
+            <a:r>
+              <a:rPr lang="en-US" sz="1050" dirty="0">
+                <a:solidFill>
+                  <a:srgbClr val="2E1B5B"/>
+                </a:solidFill>
+                <a:latin typeface="Calibri"/>
+                <a:cs typeface="Calibri"/>
+              </a:rPr>
+              <a:t xml:space="preserve">Qiskit Aer and the Rust transpiler ran out of TLS and stack; fixed in CI and Docker.</a:t>
+            </a:r>
+          </a:p>
+        </p:txBody>
+      </p:sp>
+      <p:sp>
+        <p:nvSpPr>
+          <p:cNvPr id="144" name="Future"/>
+          <p:cNvSpPr txBox="1"/>
+          <p:nvPr/>
+        </p:nvSpPr>
+        <p:spPr>
+          <a:xfrm>
+            <a:off x="4892040" y="1828800"/>
+            <a:ext cx="3566160" cy="2697480"/>
+          </a:xfrm>
+          <a:prstGeom prst="rect">
+            <a:avLst/>
+          </a:prstGeom>
+          <a:noFill/>
+          <a:ln>
+            <a:noFill/>
+          </a:ln>
+        </p:spPr>
+        <p:txBody>
+          <a:bodyPr wrap="square" lIns="0" tIns="0" rIns="0" bIns="0" rtlCol="0" anchor="t">
+            <a:normAutofit/>
+          </a:bodyPr>
+          <a:lstStyle/>
+          <a:p>
+            <a:pPr marL="0" indent="0" algn="l">
+              <a:spcAft>
+                <a:spcPts val="400"/>
+              </a:spcAft>
+              <a:buNone/>
+            </a:pPr>
+            <a:r>
+              <a:rPr lang="en-US" sz="1200" b="1" dirty="0">
+                <a:solidFill>
+                  <a:srgbClr val="E8639F"/>
+                </a:solidFill>
+                <a:latin typeface="Calibri"/>
+                <a:cs typeface="Calibri"/>
+              </a:rPr>
+              <a:t xml:space="preserve">FUTURE SCOPE</a:t>
+            </a:r>
+          </a:p>
+          <a:p>
+            <a:pPr marL="171450" indent="-171450" algn="l">
+              <a:spcAft>
+                <a:spcPts val="500"/>
+              </a:spcAft>
+              <a:buClr>
+                <a:srgbClr val="E8639F"/>
+              </a:buClr>
+              <a:buFont typeface="Arial"/>
+              <a:buChar char="•"/>
+            </a:pPr>
+            <a:r>
+              <a:rPr lang="en-US" sz="1150" dirty="0">
+                <a:solidFill>
+                  <a:srgbClr val="2E1B5B"/>
+                </a:solidFill>
+                <a:latin typeface="Calibri"/>
+                <a:cs typeface="Calibri"/>
+              </a:rPr>
+              <a:t xml:space="preserve">Train and test the projected-kernel classifier end to end on IBM hardware (about 8 minutes).</a:t>
+            </a:r>
+          </a:p>
+          <a:p>
+            <a:pPr marL="171450" indent="-171450" algn="l">
+              <a:spcAft>
+                <a:spcPts val="500"/>
+              </a:spcAft>
+              <a:buClr>
+                <a:srgbClr val="E8639F"/>
+              </a:buClr>
+              <a:buFont typeface="Arial"/>
+              <a:buChar char="•"/>
+            </a:pPr>
+            <a:r>
+              <a:rPr lang="en-US" sz="1150" dirty="0">
+                <a:solidFill>
+                  <a:srgbClr val="2E1B5B"/>
+                </a:solidFill>
+                <a:latin typeface="Calibri"/>
+                <a:cs typeface="Calibri"/>
+              </a:rPr>
+              <a:t xml:space="preserve">Tune trainable feature maps across all 6 splits.</a:t>
+            </a:r>
+          </a:p>
+          <a:p>
+            <a:pPr marL="171450" indent="-171450" algn="l">
+              <a:spcAft>
+                <a:spcPts val="500"/>
+              </a:spcAft>
+              <a:buClr>
+                <a:srgbClr val="E8639F"/>
+              </a:buClr>
+              <a:buFont typeface="Arial"/>
+              <a:buChar char="•"/>
+            </a:pPr>
+            <a:r>
+              <a:rPr lang="en-US" sz="1150" dirty="0">
+                <a:solidFill>
+                  <a:srgbClr val="2E1B5B"/>
+                </a:solidFill>
+                <a:latin typeface="Calibri"/>
+                <a:cs typeface="Calibri"/>
+              </a:rPr>
+              <a:t xml:space="preserve">Error mitigation (readout, ZNE) on the hardware kernels.</a:t>
+            </a:r>
+          </a:p>
+          <a:p>
+            <a:pPr marL="171450" indent="-171450" algn="l">
+              <a:spcAft>
+                <a:spcPts val="500"/>
+              </a:spcAft>
+              <a:buClr>
+                <a:srgbClr val="E8639F"/>
+              </a:buClr>
+              <a:buFont typeface="Arial"/>
+              <a:buChar char="•"/>
+            </a:pPr>
+            <a:r>
+              <a:rPr lang="en-US" sz="1150" dirty="0">
+                <a:solidFill>
+                  <a:srgbClr val="2E1B5B"/>
+                </a:solidFill>
+                <a:latin typeface="Calibri"/>
+                <a:cs typeface="Calibri"/>
+              </a:rPr>
+              <a:t xml:space="preserve">More drug targets in QuDock-Bench.</a:t>
+            </a:r>
+          </a:p>
+        </p:txBody>
+      </p:sp>
+      <p:sp>
+        <p:nvSpPr>
+          <p:cNvPr id="25" name="Slide Number Placeholder 0"/>
+          <p:cNvSpPr>
+            <a:spLocks noGrp="1"/>
+          </p:cNvSpPr>
+          <p:nvPr>
+            <p:ph type="sldNum" sz="quarter" idx="4294967295"/>
+          </p:nvPr>
+        </p:nvSpPr>
+        <p:spPr>
+          <a:xfrm>
+            <a:off x="8321040" y="4864608"/>
+            <a:ext cx="365760" cy="274320"/>
+          </a:xfrm>
+          <a:prstGeom prst="rect">
+            <a:avLst/>
+          </a:prstGeom>
+          <a:extLst>
+            <a:ext uri="{C572A759-6A51-4108-AA02-DFA0A04FC94B}">
+              <ma14:wrappingTextBoxFlag xmlns:ma14="http://schemas.microsoft.com/office/mac/drawingml/2011/main" xmlns="" val="0"/>
+            </a:ext>
+          </a:extLst>
+        </p:spPr>
+        <p:txBody>
+          <a:bodyPr anchor="ctr"/>
+          <a:lstStyle>
+            <a:lvl1pPr>
+              <a:defRPr sz="900">
+                <a:solidFill>
+                  <a:srgbClr val="2E1B5B"/>
+                </a:solidFill>
+              </a:defRPr>
+            </a:lvl1pPr>
+          </a:lstStyle>
+          <a:p>
+            <a:pPr algn="r"/>
+            <a:fld id="{F7021451-1387-4CA6-816F-3879F97B5CBC}" type="slidenum">
+              <a:rPr lang="en-US" b="1"/>
+              <a:t>9</a:t>
+            </a:fld>
+            <a:endParaRPr lang="en-US"/>
+          </a:p>
+        </p:txBody>
+      </p:sp>
+    </p:spTree>
+  </p:cSld>
+  <p:clrMapOvr>
+    <a:masterClrMapping/>
+  </p:clrMapOvr>
+</p:sld>
+</file>
+
+<file path=ppt/slides/slide11.xml><?xml version="1.0" encoding="utf-8"?>
+<p:sld xmlns:a="http://schemas.openxmlformats.org/drawingml/2006/main" xmlns:r="http://schemas.openxmlformats.org/officeDocument/2006/relationships" xmlns:p="http://schemas.openxmlformats.org/presentationml/2006/main">
   <p:cSld name="Slide 10">
     <p:spTree>
       <p:nvGrpSpPr>
@@ -4157,23 +4702,16 @@
 </p:sld>
 </file>
 
-<file path=ppt/slides/slide11.xml><?xml version="1.0" encoding="utf-8"?>
-<p:sld xmlns:a="http://schemas.openxmlformats.org/drawingml/2006/main" xmlns:r="http://schemas.openxmlformats.org/officeDocument/2006/relationships" xmlns:p="http://schemas.openxmlformats.org/presentationml/2006/main">
-  <p:cSld name="Slide 7">
+<file path=ppt/slides/slide12.xml><?xml version="1.0" encoding="utf-8"?>
+<p:sld xmlns:a="http://schemas.openxmlformats.org/drawingml/2006/main" xmlns:p="http://schemas.openxmlformats.org/presentationml/2006/main" xmlns:r="http://schemas.openxmlformats.org/officeDocument/2006/relationships">
+  <p:cSld>
     <p:spTree>
       <p:nvGrpSpPr>
         <p:cNvPr id="1" name=""/>
         <p:cNvGrpSpPr/>
         <p:nvPr/>
       </p:nvGrpSpPr>
-      <p:grpSpPr>
-        <a:xfrm>
-          <a:off x="0" y="0"/>
-          <a:ext cx="0" cy="0"/>
-          <a:chOff x="0" y="0"/>
-          <a:chExt cx="0" cy="0"/>
-        </a:xfrm>
-      </p:grpSpPr>
+      <p:grpSpPr/>
       <p:sp>
         <p:nvSpPr>
           <p:cNvPr id="2" name="Text 14"/>
@@ -4211,7 +4749,7 @@
                 <a:ea typeface="Georgia" pitchFamily="34" charset="-122"/>
                 <a:cs typeface="Georgia" pitchFamily="34" charset="-120"/>
               </a:rPr>
-              <a:t>Results: Noise &amp; Real Hardware</a:t>
+              <a:t>Results: Robustness &amp; Screening</a:t>
             </a:r>
             <a:endParaRPr lang="en-US" sz="2600" dirty="0"/>
           </a:p>
@@ -4321,22 +4859,22 @@
       </p:sp>
       <p:pic>
         <p:nvPicPr>
-          <p:cNvPr id="136" name="Hardware kernel heatmaps" descr="Hardware kernel heatmaps"/>
+          <p:cNvPr id="139" name="Hardware kernel heatmaps" descr="campaign_study.png"/>
           <p:cNvPicPr>
             <a:picLocks noChangeAspect="1"/>
           </p:cNvPicPr>
           <p:nvPr/>
         </p:nvPicPr>
         <p:blipFill>
-          <a:blip r:embed="rId2"/>
+          <a:blip r:embed="rId3"/>
           <a:stretch>
             <a:fillRect/>
           </a:stretch>
         </p:blipFill>
         <p:spPr>
           <a:xfrm>
-            <a:off x="566928" y="2142999"/>
-            <a:ext cx="4297680" cy="1657602"/>
+            <a:off x="558800" y="2133600"/>
+            <a:ext cx="4826000" cy="1841500"/>
           </a:xfrm>
           <a:prstGeom prst="rect">
             <a:avLst/>
@@ -4351,7 +4889,7 @@
         </p:nvSpPr>
         <p:spPr>
           <a:xfrm>
-            <a:off x="566928" y="3873753"/>
+            <a:off x="566928" y="4038600"/>
             <a:ext cx="4297680" cy="320040"/>
           </a:xfrm>
           <a:prstGeom prst="rect">
@@ -4382,7 +4920,7 @@
                 <a:latin typeface="Calibri"/>
                 <a:cs typeface="Calibri"/>
               </a:rPr>
-              <a:t xml:space="preserve">Kernel for 12 molecules (6 inhibitors first): ideal, simulated and measured on ibm_marrakesh</a:t>
+              <a:t xml:space="preserve">Screening campaign: 50 starting molecules, 25 assays per round for 8 rounds, 3 seeds</a:t>
             </a:r>
           </a:p>
         </p:txBody>
@@ -4482,7 +5020,7 @@
                 <a:latin typeface="Calibri"/>
                 <a:cs typeface="Calibri"/>
               </a:rPr>
-              <a:t xml:space="preserve">Simulated IBM Torino: </a:t>
+              <a:t xml:space="preserve">6 scaffold splits: </a:t>
             </a:r>
             <a:r>
               <a:rPr lang="en-US" sz="1050" dirty="0">
@@ -4492,7 +5030,7 @@
                 <a:latin typeface="Calibri"/>
                 <a:cs typeface="Calibri"/>
               </a:rPr>
-              <a:t xml:space="preserve">device noise gives 8 to 13% kernel error (shots alone 1.4 to 6.4%).</a:t>
+              <a:t xml:space="preserve">split choice moves ROC-AUC by 0.019 to 0.044, seed by at most 0.008; classical stays ahead on all six.</a:t>
             </a:r>
           </a:p>
           <a:p>
@@ -4514,7 +5052,7 @@
                 <a:latin typeface="Calibri"/>
                 <a:cs typeface="Calibri"/>
               </a:rPr>
-              <a:t xml:space="preserve">Accuracy holds: </a:t>
+              <a:t xml:space="preserve">Screening: </a:t>
             </a:r>
             <a:r>
               <a:rPr lang="en-US" sz="1050" dirty="0">
@@ -4524,7 +5062,7 @@
                 <a:latin typeface="Calibri"/>
                 <a:cs typeface="Calibri"/>
               </a:rPr>
-              <a:t xml:space="preserve">test ROC-AUC stays 0.62 to 0.66 in every noise setting.</a:t>
+              <a:t xml:space="preserve">189 inhibitors found in 250 tests vs 104 at random, +85 hits; the hybrid kernel ranks first on all 3 seeds.</a:t>
             </a:r>
           </a:p>
           <a:p>
@@ -4546,7 +5084,7 @@
                 <a:latin typeface="Calibri"/>
                 <a:cs typeface="Calibri"/>
               </a:rPr>
-              <a:t xml:space="preserve">Real ibm_marrakesh: </a:t>
+              <a:t xml:space="preserve">Calibrated confidence: </a:t>
             </a:r>
             <a:r>
               <a:rPr lang="en-US" sz="1050" dirty="0">
@@ -4556,7 +5094,7 @@
                 <a:latin typeface="Calibri"/>
                 <a:cs typeface="Calibri"/>
               </a:rPr>
-              <a:t xml:space="preserve">66 circuits, 1,024 shots, 20 s of quantum time.</a:t>
+              <a:t xml:space="preserve">conformal sets; a 90% promise delivers 0.66 to 0.86 under scaffold shift, and we report it.</a:t>
             </a:r>
           </a:p>
           <a:p>
@@ -4578,7 +5116,7 @@
                 <a:latin typeface="Calibri"/>
                 <a:cs typeface="Calibri"/>
               </a:rPr>
-              <a:t xml:space="preserve">Kernel error: </a:t>
+              <a:t xml:space="preserve">Explanations: </a:t>
             </a:r>
             <a:r>
               <a:rPr lang="en-US" sz="1050" dirty="0">
@@ -4588,39 +5126,7 @@
                 <a:latin typeface="Calibri"/>
                 <a:cs typeface="Calibri"/>
               </a:rPr>
-              <a:t xml:space="preserve">17.5% on hardware vs 10.3% simulated, yet correlation with ideal is 0.996.</a:t>
-            </a:r>
-          </a:p>
-          <a:p>
-            <a:pPr marL="171450" indent="-171450" algn="l">
-              <a:spcAft>
-                <a:spcPts val="300"/>
-              </a:spcAft>
-              <a:buClr>
-                <a:srgbClr val="5B3BA8"/>
-              </a:buClr>
-              <a:buFont typeface="Arial"/>
-              <a:buChar char="•"/>
-            </a:pPr>
-            <a:r>
-              <a:rPr lang="en-US" sz="1050" b="1" dirty="0">
-                <a:solidFill>
-                  <a:srgbClr val="2E1B5B"/>
-                </a:solidFill>
-                <a:latin typeface="Calibri"/>
-                <a:cs typeface="Calibri"/>
-              </a:rPr>
-              <a:t xml:space="preserve">Why it works: </a:t>
-            </a:r>
-            <a:r>
-              <a:rPr lang="en-US" sz="1050" dirty="0">
-                <a:solidFill>
-                  <a:srgbClr val="2E1B5B"/>
-                </a:solidFill>
-                <a:latin typeface="Calibri"/>
-                <a:cs typeface="Calibri"/>
-              </a:rPr>
-              <a:t xml:space="preserve">noise shrinks all values a little, so the ranking of molecules survives.</a:t>
+              <a:t xml:space="preserve">deleting highlighted atoms costs 0.563 of score vs 0.381 for random atoms.</a:t>
             </a:r>
           </a:p>
         </p:txBody>
@@ -5066,7 +5572,7 @@
                 <a:latin typeface="Calibri"/>
                 <a:cs typeface="Calibri"/>
               </a:rPr>
-              <a:t xml:space="preserve">Can a quantum kernel find BACE-1 inhibitors better than classical ML when data is scarce and hardware is noisy?</a:t>
+              <a:t xml:space="preserve">Can a quantum kernel find BACE-1 inhibitors as well as or better than tuned classical ML, on real chemistry and real IBM hardware?</a:t>
             </a:r>
           </a:p>
         </p:txBody>
@@ -5530,7 +6036,7 @@
                 <a:latin typeface="Calibri"/>
                 <a:cs typeface="Calibri"/>
               </a:rPr>
-              <a:t xml:space="preserve">Compare it fairly with SVM-RBF, Random Forest and Logistic Regression on identical features.</a:t>
+              <a:t xml:space="preserve">Compare fidelity, projected, hybrid and trainable quantum kernels with tuned classical models on identical features.</a:t>
             </a:r>
           </a:p>
           <a:p>
@@ -5558,7 +6064,7 @@
                 <a:latin typeface="Calibri"/>
                 <a:cs typeface="Calibri"/>
               </a:rPr>
-              <a:t xml:space="preserve">Test the small-data claim (25 to 1,210 molecules) and scaling (2 to 10 qubits).</a:t>
+              <a:t xml:space="preserve">Attack our own result: 6 scaffold splits, 10 seeds, paired bootstrap and Wilcoxon tests, 3 datasets.</a:t>
             </a:r>
           </a:p>
           <a:p>
@@ -5586,7 +6092,35 @@
                 <a:latin typeface="Calibri"/>
                 <a:cs typeface="Calibri"/>
               </a:rPr>
-              <a:t xml:space="preserve">Measure how noise affects the kernel, in simulation and on a real IBM quantum computer.</a:t>
+              <a:t xml:space="preserve">Measure hardware noise and price a full run on a real IBM quantum computer.</a:t>
+            </a:r>
+          </a:p>
+          <a:p>
+            <a:pPr marL="0" indent="0" algn="l">
+              <a:spcAft>
+                <a:spcPts val="500"/>
+              </a:spcAft>
+              <a:buNone/>
+            </a:pPr>
+            <a:r>
+              <a:rPr lang="en-US" sz="1150" b="1" dirty="0">
+                <a:solidFill>
+                  <a:srgbClr val="E8639F"/>
+                </a:solidFill>
+                <a:latin typeface="Calibri"/>
+                <a:cs typeface="Calibri"/>
+              </a:rPr>
+              <a:t xml:space="preserve">5.  </a:t>
+            </a:r>
+            <a:r>
+              <a:rPr lang="en-US" sz="1150" dirty="0">
+                <a:solidFill>
+                  <a:srgbClr val="2E1B5B"/>
+                </a:solidFill>
+                <a:latin typeface="Calibri"/>
+                <a:cs typeface="Calibri"/>
+              </a:rPr>
+              <a:t xml:space="preserve">Turn it into a tool: a screening campaign, calibrated confidence and atom-level explanations.</a:t>
             </a:r>
           </a:p>
         </p:txBody>
@@ -5652,7 +6186,7 @@
                 <a:latin typeface="Calibri"/>
                 <a:cs typeface="Calibri"/>
               </a:rPr>
-              <a:t xml:space="preserve">Realistic split: </a:t>
+              <a:t xml:space="preserve">Hybrid kernel: </a:t>
             </a:r>
             <a:r>
               <a:rPr lang="en-US" sz="1150" dirty="0">
@@ -5662,7 +6196,7 @@
                 <a:latin typeface="Calibri"/>
                 <a:cs typeface="Calibri"/>
               </a:rPr>
-              <a:t xml:space="preserve">scaffold split, so test molecules come from unseen chemical families.</a:t>
+              <a:t xml:space="preserve">quantum kernel mixed with Tanimoto similarity, weight chosen by cross-validation: our best quantum model at 0.776.</a:t>
             </a:r>
           </a:p>
           <a:p>
@@ -5684,7 +6218,7 @@
                 <a:latin typeface="Calibri"/>
                 <a:cs typeface="Calibri"/>
               </a:rPr>
-              <a:t xml:space="preserve">Real statistics: </a:t>
+              <a:t xml:space="preserve">Trainable feature map: </a:t>
             </a:r>
             <a:r>
               <a:rPr lang="en-US" sz="1150" dirty="0">
@@ -5694,7 +6228,7 @@
                 <a:latin typeface="Calibri"/>
                 <a:cs typeface="Calibri"/>
               </a:rPr>
-              <a:t xml:space="preserve">multiple seeds and paired Wilcoxon tests, not a single lucky run.</a:t>
+              <a:t xml:space="preserve">per-angle weights and RY rotations tuned by kernel-target alignment: +0.012, p = 0.03.</a:t>
             </a:r>
           </a:p>
           <a:p>
@@ -5716,7 +6250,7 @@
                 <a:latin typeface="Calibri"/>
                 <a:cs typeface="Calibri"/>
               </a:rPr>
-              <a:t xml:space="preserve">Kernel diagnostics: </a:t>
+              <a:t xml:space="preserve">Beating concentration: </a:t>
             </a:r>
             <a:r>
               <a:rPr lang="en-US" sz="1150" dirty="0">
@@ -5726,7 +6260,7 @@
                 <a:latin typeface="Calibri"/>
                 <a:cs typeface="Calibri"/>
               </a:rPr>
-              <a:t xml:space="preserve">geometric difference, label alignment and concentration.</a:t>
+              <a:t xml:space="preserve">bandwidth tuned by alignment keeps the kernel 9 to 17× more spread out up to 14 qubits.</a:t>
             </a:r>
           </a:p>
           <a:p>
@@ -5748,7 +6282,7 @@
                 <a:latin typeface="Calibri"/>
                 <a:cs typeface="Calibri"/>
               </a:rPr>
-              <a:t xml:space="preserve">Hardware check: </a:t>
+              <a:t xml:space="preserve">Honest by construction: </a:t>
             </a:r>
             <a:r>
               <a:rPr lang="en-US" sz="1150" dirty="0">
@@ -5758,7 +6292,7 @@
                 <a:latin typeface="Calibri"/>
                 <a:cs typeface="Calibri"/>
               </a:rPr>
-              <a:t xml:space="preserve">simulation compared with ibm_marrakesh, which caught a flaw in our own noise study.</a:t>
+              <a:t xml:space="preserve">6 splits, 3 datasets and a hardware cost model; we report where classical still wins.</a:t>
             </a:r>
           </a:p>
         </p:txBody>
@@ -6174,7 +6708,7 @@
                 <a:latin typeface="Calibri"/>
                 <a:cs typeface="Calibri"/>
               </a:rPr>
-              <a:t xml:space="preserve">ECFP4 fingerprint, PCA to one angle per qubit</a:t>
+              <a:t xml:space="preserve">ECFP4 + 10 descriptors, supervised PLS to n angles</a:t>
             </a:r>
           </a:p>
         </p:txBody>
@@ -6284,7 +6818,7 @@
                 <a:latin typeface="Calibri"/>
                 <a:cs typeface="Calibri"/>
               </a:rPr>
-              <a:t xml:space="preserve">ZZ feature map, fidelity kernel</a:t>
+              <a:t xml:space="preserve">Trainable ZZ map; fidelity, projected or hybrid kernel</a:t>
             </a:r>
           </a:p>
         </p:txBody>
@@ -6394,7 +6928,7 @@
                 <a:latin typeface="Calibri"/>
                 <a:cs typeface="Calibri"/>
               </a:rPr>
-              <a:t xml:space="preserve">Kernel SVM (QSVC) vs 3 classical models</a:t>
+              <a:t xml:space="preserve">Kernel SVM vs 6 tuned classical models</a:t>
             </a:r>
           </a:p>
         </p:txBody>
@@ -6460,7 +6994,7 @@
                 <a:latin typeface="Calibri"/>
                 <a:cs typeface="Calibri"/>
               </a:rPr>
-              <a:t xml:space="preserve">Each molecule is compressed to a few angles and loaded into a ZZ feature map circuit.</a:t>
+              <a:t xml:space="preserve">Each molecule is compressed with supervised PLS into a few angles and loaded into a ZZ feature map circuit.</a:t>
             </a:r>
           </a:p>
           <a:p>
@@ -6492,7 +7026,7 @@
                 <a:latin typeface="Calibri"/>
                 <a:cs typeface="Calibri"/>
               </a:rPr>
-              <a:t xml:space="preserve">k(x, y) = |⟨φ(x)|φ(y)⟩|², the overlap of two molecules' quantum states.</a:t>
+              <a:t xml:space="preserve">k(x, y) = |⟨φ(x)|φ(y)⟩|², the overlap of two molecules' quantum states; the projected kernel needs one circuit per molecule.</a:t>
             </a:r>
           </a:p>
           <a:p>
@@ -6514,7 +7048,7 @@
                 <a:latin typeface="Calibri"/>
                 <a:cs typeface="Calibri"/>
               </a:rPr>
-              <a:t xml:space="preserve">An SVM learns on this kernel; classical models get exactly the same features.</a:t>
+              <a:t xml:space="preserve">An SVM learns on this kernel; classical models get exactly the same features, splits and seeds.</a:t>
             </a:r>
           </a:p>
         </p:txBody>
@@ -6622,7 +7156,7 @@
                 <a:latin typeface="Calibri"/>
                 <a:cs typeface="Calibri"/>
               </a:rPr>
-              <a:t xml:space="preserve">geometric difference vs RBF up to about 100.</a:t>
+              <a:t xml:space="preserve">the hybrid kernel keeps a real quantum share (w = 0.1 to 0.5) after cross-validation.</a:t>
             </a:r>
           </a:p>
           <a:p>
@@ -6644,7 +7178,7 @@
                 <a:latin typeface="Calibri"/>
                 <a:cs typeface="Calibri"/>
               </a:rPr>
-              <a:t xml:space="preserve">Better label alignment: </a:t>
+              <a:t xml:space="preserve">Trainable: </a:t>
             </a:r>
             <a:r>
               <a:rPr lang="en-US" sz="1100" dirty="0">
@@ -6654,7 +7188,7 @@
                 <a:latin typeface="Calibri"/>
                 <a:cs typeface="Calibri"/>
               </a:rPr>
-              <a:t xml:space="preserve">0.15 to 0.18 vs 0.09 to 0.10 for RBF.</a:t>
+              <a:t xml:space="preserve">learning the feature map is the one place quantum beats its own baseline (+0.012, p = 0.03).</a:t>
             </a:r>
           </a:p>
         </p:txBody>
@@ -7047,7 +7581,7 @@
                 <a:latin typeface="Calibri"/>
                 <a:cs typeface="Calibri"/>
               </a:rPr>
-              <a:t xml:space="preserve">ECFP4 (2048 bits), standardise, PCA to n values, scale to [0, π].</a:t>
+              <a:t xml:space="preserve">ECFP4 (2048 bits) + 10 RDKit descriptors, supervised PLS to n values, scaled to [0, π].</a:t>
             </a:r>
           </a:p>
           <a:p>
@@ -7079,7 +7613,7 @@
                 <a:latin typeface="Calibri"/>
                 <a:cs typeface="Calibri"/>
               </a:rPr>
-              <a:t xml:space="preserve">Hadamard + Z rotations, ZZ entanglers between neighbours; bandwidth tuned.</a:t>
+              <a:t xml:space="preserve">Hadamards, RZ(2wᵢxᵢ), ZZ entanglers between neighbours, trainable RY(θᵢ); bandwidth by kernel-target alignment.</a:t>
             </a:r>
           </a:p>
           <a:p>
@@ -7101,7 +7635,7 @@
                 <a:latin typeface="Calibri"/>
                 <a:cs typeface="Calibri"/>
               </a:rPr>
-              <a:t xml:space="preserve">Kernel: </a:t>
+              <a:t xml:space="preserve">Kernels: </a:t>
             </a:r>
             <a:r>
               <a:rPr lang="en-US" sz="1050" dirty="0">
@@ -7111,7 +7645,7 @@
                 <a:latin typeface="Calibri"/>
                 <a:cs typeface="Calibri"/>
               </a:rPr>
-              <a:t xml:space="preserve">compute-uncompute circuit; k = probability of all zeros. Exact statevector for benchmarks, shots for noise and hardware.</a:t>
+              <a:t xml:space="preserve">fidelity (compute-uncompute), projected (⟨X⟩⟨Y⟩⟨Z⟩ per qubit, 700× fewer circuits) and hybrid w·K_Q + (1 − w)·K_Tanimoto.</a:t>
             </a:r>
           </a:p>
           <a:p>
@@ -7143,7 +7677,7 @@
                 <a:latin typeface="Calibri"/>
                 <a:cs typeface="Calibri"/>
               </a:rPr>
-              <a:t xml:space="preserve">SVM on the precomputed kernel; C and bandwidth by inner cross-validation.</a:t>
+              <a:t xml:space="preserve">SVM on the precomputed kernel; C, bandwidth and w by inner cross-validation.</a:t>
             </a:r>
           </a:p>
         </p:txBody>
@@ -7459,7 +7993,7 @@
                 <a:latin typeface="Calibri"/>
                 <a:cs typeface="Calibri"/>
               </a:rPr>
-              <a:t xml:space="preserve">BACE download, cleaning, scaffold split, fingerprints, PCA</a:t>
+              <a:t xml:space="preserve">BACE, BBBP and ClinTox; scaffold split and 6 reseeded splits; ECFP4, descriptors, PLS / PCA</a:t>
             </a:r>
           </a:p>
           <a:p>
@@ -7491,7 +8025,7 @@
                 <a:latin typeface="Calibri"/>
                 <a:cs typeface="Calibri"/>
               </a:rPr>
-              <a:t xml:space="preserve">ZZ fidelity kernel + QSVC; SVM-RBF, RF, LogReg</a:t>
+              <a:t xml:space="preserve">fidelity, projected, hybrid, trainable and graph kernels, Nyström; SVM-RBF, RF, boosting, Tanimoto SVM</a:t>
             </a:r>
           </a:p>
           <a:p>
@@ -7513,7 +8047,7 @@
                 <a:latin typeface="Calibri"/>
                 <a:cs typeface="Calibri"/>
               </a:rPr>
-              <a:t xml:space="preserve">benchmark / sweep / analysis: </a:t>
+              <a:t xml:space="preserve">analysis: </a:t>
             </a:r>
             <a:r>
               <a:rPr lang="en-US" sz="1050" dirty="0">
@@ -7523,7 +8057,7 @@
                 <a:latin typeface="Calibri"/>
                 <a:cs typeface="Calibri"/>
               </a:rPr>
-              <a:t xml:space="preserve">learning curves, qubit sweep, kernel diagnostics, Wilcoxon tests</a:t>
+              <a:t xml:space="preserve">learning curves, concentration, bootstrap and Wilcoxon tests, conformal sets, atom explanations</a:t>
             </a:r>
           </a:p>
           <a:p>
@@ -7545,7 +8079,7 @@
                 <a:latin typeface="Calibri"/>
                 <a:cs typeface="Calibri"/>
               </a:rPr>
-              <a:t xml:space="preserve">noise / hardware: </a:t>
+              <a:t xml:space="preserve">hardware / screening: </a:t>
             </a:r>
             <a:r>
               <a:rPr lang="en-US" sz="1050" dirty="0">
@@ -7555,7 +8089,7 @@
                 <a:latin typeface="Calibri"/>
                 <a:cs typeface="Calibri"/>
               </a:rPr>
-              <a:t xml:space="preserve">shot-based kernels on FakeTorino and on a real IBM device</a:t>
+              <a:t xml:space="preserve">FakeTorino noise, ibm_marrakesh run, cost model, active-learning campaign</a:t>
             </a:r>
           </a:p>
           <a:p>
@@ -7577,7 +8111,7 @@
                 <a:latin typeface="Calibri"/>
                 <a:cs typeface="Calibri"/>
               </a:rPr>
-              <a:t xml:space="preserve">cli: </a:t>
+              <a:t xml:space="preserve">delivery: </a:t>
             </a:r>
             <a:r>
               <a:rPr lang="en-US" sz="1050" dirty="0">
@@ -7587,7 +8121,7 @@
                 <a:latin typeface="Calibri"/>
                 <a:cs typeface="Calibri"/>
               </a:rPr>
-              <a:t xml:space="preserve">qudock benchmark | sweep | noise | hardware</a:t>
+              <a:t xml:space="preserve">qudock CLI, HTTP API, Streamlit web app, docs site, 182 tests</a:t>
             </a:r>
           </a:p>
         </p:txBody>
@@ -8251,7 +8785,7 @@
                 <a:latin typeface="Calibri"/>
                 <a:cs typeface="Calibri"/>
               </a:rPr>
-              <a:t xml:space="preserve">Pinned versions, unit tests and CI on every push. Runs on a laptop; hardware run on IBM Quantum open plan.</a:t>
+              <a:t xml:space="preserve">Pinned versions, 182 tests and CI on every push. One command regenerates every number; hardware run on the IBM Quantum open plan.</a:t>
             </a:r>
           </a:p>
         </p:txBody>
@@ -8473,22 +9007,22 @@
       </p:sp>
       <p:pic>
         <p:nvPicPr>
-          <p:cNvPr id="134" name="Learning curve: test ROC-AUC vs training molecules" descr="Learning curve: test ROC-AUC vs training molecules"/>
+          <p:cNvPr id="136" name="Learning curve: test ROC-AUC vs training molecules" descr="scorecard.png"/>
           <p:cNvPicPr>
             <a:picLocks noChangeAspect="1"/>
           </p:cNvPicPr>
           <p:nvPr/>
         </p:nvPicPr>
         <p:blipFill>
-          <a:blip r:embed="rId3"/>
+          <a:blip r:embed="rId4"/>
           <a:stretch>
             <a:fillRect/>
           </a:stretch>
         </p:blipFill>
         <p:spPr>
           <a:xfrm>
-            <a:off x="692658" y="1801368"/>
-            <a:ext cx="4046220" cy="2697480"/>
+            <a:off x="685800" y="1790700"/>
+            <a:ext cx="4445000" cy="2692400"/>
           </a:xfrm>
           <a:prstGeom prst="rect">
             <a:avLst/>
@@ -8590,7 +9124,7 @@
                 <a:latin typeface="Calibri"/>
                 <a:cs typeface="Calibri"/>
               </a:rPr>
-              <a:t xml:space="preserve">Sample efficiency (6 qubits, 5 seeds): </a:t>
+              <a:t xml:space="preserve">Best quantum: </a:t>
             </a:r>
             <a:r>
               <a:rPr lang="en-US" sz="1050" dirty="0">
@@ -8600,7 +9134,7 @@
                 <a:latin typeface="Calibri"/>
                 <a:cs typeface="Calibri"/>
               </a:rPr>
-              <a:t xml:space="preserve">at 1,210 molecules QSVC 0.687 ROC-AUC vs Random Forest 0.740.</a:t>
+              <a:t xml:space="preserve">hybrid quantum + Tanimoto at 0.776 ROC-AUC on BACE, up from 0.687 in round one.</a:t>
             </a:r>
           </a:p>
           <a:p>
@@ -8622,7 +9156,7 @@
                 <a:latin typeface="Calibri"/>
                 <a:cs typeface="Calibri"/>
               </a:rPr>
-              <a:t xml:space="preserve">No small-data edge: </a:t>
+              <a:t xml:space="preserve">Best classical: </a:t>
             </a:r>
             <a:r>
               <a:rPr lang="en-US" sz="1050" dirty="0">
@@ -8632,7 +9166,7 @@
                 <a:latin typeface="Calibri"/>
                 <a:cs typeface="Calibri"/>
               </a:rPr>
-              <a:t xml:space="preserve">with 25 to 50 molecules QSVC is the weakest model (0.59).</a:t>
+              <a:t xml:space="preserve">Random Forest on fingerprints 0.782, Tanimoto SVM 0.781. The gap shrank from −0.053 to −0.006.</a:t>
             </a:r>
           </a:p>
           <a:p>
@@ -8654,7 +9188,7 @@
                 <a:latin typeface="Calibri"/>
                 <a:cs typeface="Calibri"/>
               </a:rPr>
-              <a:t xml:space="preserve">Qubit sweep: </a:t>
+              <a:t xml:space="preserve">Second dataset: </a:t>
             </a:r>
             <a:r>
               <a:rPr lang="en-US" sz="1050" dirty="0">
@@ -8664,7 +9198,7 @@
                 <a:latin typeface="Calibri"/>
                 <a:cs typeface="Calibri"/>
               </a:rPr>
-              <a:t xml:space="preserve">QSVC best at 8 qubits (0.719), above SVM-RBF (0.705), below RF (0.729).</a:t>
+              <a:t xml:space="preserve">BBBP hybrid 0.827 vs 0.829, a tie (p = 0.68).</a:t>
             </a:r>
           </a:p>
           <a:p>
@@ -8686,7 +9220,7 @@
                 <a:latin typeface="Calibri"/>
                 <a:cs typeface="Calibri"/>
               </a:rPr>
-              <a:t xml:space="preserve">Concentration: </a:t>
+              <a:t xml:space="preserve">Trained feature map: </a:t>
             </a:r>
             <a:r>
               <a:rPr lang="en-US" sz="1050" dirty="0">
@@ -8696,7 +9230,7 @@
                 <a:latin typeface="Calibri"/>
                 <a:cs typeface="Calibri"/>
               </a:rPr>
-              <a:t xml:space="preserve">kernel variance falls from 0.075 (2 qubits) to 0.005 (10 qubits).</a:t>
+              <a:t xml:space="preserve">+0.012 over the fixed ZZ map, 14 of 20 runs (p = 0.03).</a:t>
             </a:r>
           </a:p>
           <a:p>
@@ -8728,7 +9262,7 @@
                 <a:latin typeface="Calibri"/>
                 <a:cs typeface="Calibri"/>
               </a:rPr>
-              <a:t xml:space="preserve">competitive with RBF SVM, not better than RF; gaps not significant (p ≥ 0.06).</a:t>
+              <a:t xml:space="preserve">quantum reaches the classical ceiling but does not beat it, and we say so.</a:t>
             </a:r>
           </a:p>
         </p:txBody>
@@ -8787,6 +9321,527 @@
 </file>
 
 <file path=ppt/slides/slide8.xml><?xml version="1.0" encoding="utf-8"?>
+<p:sld xmlns:a="http://schemas.openxmlformats.org/drawingml/2006/main" xmlns:r="http://schemas.openxmlformats.org/officeDocument/2006/relationships" xmlns:p="http://schemas.openxmlformats.org/presentationml/2006/main">
+  <p:cSld name="Slide 7">
+    <p:spTree>
+      <p:nvGrpSpPr>
+        <p:cNvPr id="1" name=""/>
+        <p:cNvGrpSpPr/>
+        <p:nvPr/>
+      </p:nvGrpSpPr>
+      <p:grpSpPr>
+        <a:xfrm>
+          <a:off x="0" y="0"/>
+          <a:ext cx="0" cy="0"/>
+          <a:chOff x="0" y="0"/>
+          <a:chExt cx="0" cy="0"/>
+        </a:xfrm>
+      </p:grpSpPr>
+      <p:sp>
+        <p:nvSpPr>
+          <p:cNvPr id="2" name="Text 14"/>
+          <p:cNvSpPr>
+            <a:spLocks noGrp="1"/>
+          </p:cNvSpPr>
+          <p:nvPr>
+            <p:ph type="title" idx="120" hasCustomPrompt="1"/>
+          </p:nvPr>
+        </p:nvSpPr>
+        <p:spPr>
+          <a:xfrm>
+            <a:off x="457200" y="841248"/>
+            <a:ext cx="6309360" cy="594360"/>
+          </a:xfrm>
+          <a:prstGeom prst="rect">
+            <a:avLst/>
+          </a:prstGeom>
+          <a:noFill/>
+          <a:ln/>
+        </p:spPr>
+        <p:txBody>
+          <a:bodyPr wrap="square" lIns="0" tIns="0" rIns="0" bIns="0" rtlCol="0" anchor="ctr"/>
+          <a:lstStyle/>
+          <a:p>
+            <a:pPr marL="0" indent="0" algn="l">
+              <a:buNone/>
+            </a:pPr>
+            <a:r>
+              <a:rPr lang="en-US" sz="2600" b="1" dirty="0">
+                <a:solidFill>
+                  <a:srgbClr val="2E1B5B"/>
+                </a:solidFill>
+                <a:latin typeface="Georgia" pitchFamily="34" charset="0"/>
+                <a:ea typeface="Georgia" pitchFamily="34" charset="-122"/>
+                <a:cs typeface="Georgia" pitchFamily="34" charset="-120"/>
+              </a:rPr>
+              <a:t>Results: Hardware &amp; Cost</a:t>
+            </a:r>
+            <a:endParaRPr lang="en-US" sz="2600" dirty="0"/>
+          </a:p>
+        </p:txBody>
+      </p:sp>
+      <p:sp>
+        <p:nvSpPr>
+          <p:cNvPr id="3" name="Title accent"/>
+          <p:cNvSpPr/>
+          <p:nvPr/>
+        </p:nvSpPr>
+        <p:spPr>
+          <a:xfrm>
+            <a:off x="457200" y="1463040"/>
+            <a:ext cx="256032" cy="45720"/>
+          </a:xfrm>
+          <a:prstGeom prst="rect">
+            <a:avLst/>
+          </a:prstGeom>
+          <a:solidFill>
+            <a:srgbClr val="7C93F0"/>
+          </a:solidFill>
+          <a:ln w="12700">
+            <a:solidFill>
+              <a:srgbClr val="7C93F0"/>
+            </a:solidFill>
+            <a:prstDash val="solid"/>
+          </a:ln>
+        </p:spPr>
+      </p:sp>
+      <p:sp>
+        <p:nvSpPr>
+          <p:cNvPr id="4" name="Title accent"/>
+          <p:cNvSpPr/>
+          <p:nvPr/>
+        </p:nvSpPr>
+        <p:spPr>
+          <a:xfrm>
+            <a:off x="731520" y="1463040"/>
+            <a:ext cx="256032" cy="45720"/>
+          </a:xfrm>
+          <a:prstGeom prst="rect">
+            <a:avLst/>
+          </a:prstGeom>
+          <a:solidFill>
+            <a:srgbClr val="E8639F"/>
+          </a:solidFill>
+          <a:ln w="12700">
+            <a:solidFill>
+              <a:srgbClr val="E8639F"/>
+            </a:solidFill>
+            <a:prstDash val="solid"/>
+          </a:ln>
+        </p:spPr>
+      </p:sp>
+      <p:sp>
+        <p:nvSpPr>
+          <p:cNvPr id="5" name="Title accent"/>
+          <p:cNvSpPr/>
+          <p:nvPr/>
+        </p:nvSpPr>
+        <p:spPr>
+          <a:xfrm>
+            <a:off x="1005840" y="1463040"/>
+            <a:ext cx="256032" cy="45720"/>
+          </a:xfrm>
+          <a:prstGeom prst="rect">
+            <a:avLst/>
+          </a:prstGeom>
+          <a:solidFill>
+            <a:srgbClr val="5B3BA8"/>
+          </a:solidFill>
+          <a:ln w="12700">
+            <a:solidFill>
+              <a:srgbClr val="5B3BA8"/>
+            </a:solidFill>
+            <a:prstDash val="solid"/>
+          </a:ln>
+        </p:spPr>
+      </p:sp>
+      <p:sp>
+        <p:nvSpPr>
+          <p:cNvPr id="6" name="Insert area"/>
+          <p:cNvSpPr/>
+          <p:nvPr/>
+        </p:nvSpPr>
+        <p:spPr>
+          <a:xfrm>
+            <a:off x="457200" y="1691640"/>
+            <a:ext cx="4937760" cy="2926080"/>
+          </a:xfrm>
+          <a:prstGeom prst="roundRect">
+            <a:avLst>
+              <a:gd name="adj" fmla="val 2500"/>
+            </a:avLst>
+          </a:prstGeom>
+          <a:solidFill>
+            <a:srgbClr val="EEF0FE"/>
+          </a:solidFill>
+          <a:ln w="15875">
+            <a:solidFill>
+              <a:srgbClr val="7C93F0"/>
+            </a:solidFill>
+            <a:prstDash val="dash"/>
+          </a:ln>
+        </p:spPr>
+      </p:sp>
+      <p:pic>
+        <p:nvPicPr>
+          <p:cNvPr id="136" name="Hardware kernel heatmaps" descr="Hardware kernel heatmaps"/>
+          <p:cNvPicPr>
+            <a:picLocks noChangeAspect="1"/>
+          </p:cNvPicPr>
+          <p:nvPr/>
+        </p:nvPicPr>
+        <p:blipFill>
+          <a:blip r:embed="rId2"/>
+          <a:stretch>
+            <a:fillRect/>
+          </a:stretch>
+        </p:blipFill>
+        <p:spPr>
+          <a:xfrm>
+            <a:off x="566928" y="2142999"/>
+            <a:ext cx="4297680" cy="1657602"/>
+          </a:xfrm>
+          <a:prstGeom prst="rect">
+            <a:avLst/>
+          </a:prstGeom>
+        </p:spPr>
+      </p:pic>
+      <p:sp>
+        <p:nvSpPr>
+          <p:cNvPr id="137" name="Heatmap caption"/>
+          <p:cNvSpPr txBox="1"/>
+          <p:nvPr/>
+        </p:nvSpPr>
+        <p:spPr>
+          <a:xfrm>
+            <a:off x="566928" y="3873753"/>
+            <a:ext cx="4297680" cy="320040"/>
+          </a:xfrm>
+          <a:prstGeom prst="rect">
+            <a:avLst/>
+          </a:prstGeom>
+          <a:noFill/>
+          <a:ln>
+            <a:noFill/>
+          </a:ln>
+        </p:spPr>
+        <p:txBody>
+          <a:bodyPr wrap="square" lIns="0" tIns="0" rIns="0" bIns="0" rtlCol="0" anchor="t">
+            <a:normAutofit/>
+          </a:bodyPr>
+          <a:lstStyle/>
+          <a:p>
+            <a:pPr marL="0" indent="0" algn="ctr">
+              <a:spcAft>
+                <a:spcPts val="0"/>
+              </a:spcAft>
+              <a:buNone/>
+            </a:pPr>
+            <a:r>
+              <a:rPr lang="en-US" sz="950" i="1" dirty="0">
+                <a:solidFill>
+                  <a:srgbClr val="6F7399"/>
+                </a:solidFill>
+                <a:latin typeface="Calibri"/>
+                <a:cs typeface="Calibri"/>
+              </a:rPr>
+              <a:t xml:space="preserve">Kernel for 12 molecules (6 inhibitors first): ideal, simulated and measured on ibm_marrakesh</a:t>
+            </a:r>
+          </a:p>
+        </p:txBody>
+      </p:sp>
+      <p:sp>
+        <p:nvSpPr>
+          <p:cNvPr id="8" name="Content card"/>
+          <p:cNvSpPr/>
+          <p:nvPr/>
+        </p:nvSpPr>
+        <p:spPr>
+          <a:xfrm>
+            <a:off x="5577840" y="1691640"/>
+            <a:ext cx="3108960" cy="2926080"/>
+          </a:xfrm>
+          <a:prstGeom prst="roundRect">
+            <a:avLst>
+              <a:gd name="adj" fmla="val 2500"/>
+            </a:avLst>
+          </a:prstGeom>
+          <a:solidFill>
+            <a:srgbClr val="FFFFFF"/>
+          </a:solidFill>
+          <a:ln w="9525">
+            <a:solidFill>
+              <a:srgbClr val="B8BDEB"/>
+            </a:solidFill>
+            <a:prstDash val="solid"/>
+          </a:ln>
+        </p:spPr>
+      </p:sp>
+      <p:sp>
+        <p:nvSpPr>
+          <p:cNvPr id="9" name="Card accent"/>
+          <p:cNvSpPr/>
+          <p:nvPr/>
+        </p:nvSpPr>
+        <p:spPr>
+          <a:xfrm>
+            <a:off x="5806440" y="1691640"/>
+            <a:ext cx="822960" cy="54864"/>
+          </a:xfrm>
+          <a:prstGeom prst="rect">
+            <a:avLst/>
+          </a:prstGeom>
+          <a:solidFill>
+            <a:srgbClr val="5B3BA8"/>
+          </a:solidFill>
+          <a:ln w="12700">
+            <a:solidFill>
+              <a:srgbClr val="5B3BA8"/>
+            </a:solidFill>
+            <a:prstDash val="solid"/>
+          </a:ln>
+        </p:spPr>
+      </p:sp>
+      <p:sp>
+        <p:nvSpPr>
+          <p:cNvPr id="138" name="Key details"/>
+          <p:cNvSpPr txBox="1"/>
+          <p:nvPr/>
+        </p:nvSpPr>
+        <p:spPr>
+          <a:xfrm>
+            <a:off x="5760720" y="1810512"/>
+            <a:ext cx="2743200" cy="2697480"/>
+          </a:xfrm>
+          <a:prstGeom prst="rect">
+            <a:avLst/>
+          </a:prstGeom>
+          <a:noFill/>
+          <a:ln>
+            <a:noFill/>
+          </a:ln>
+        </p:spPr>
+        <p:txBody>
+          <a:bodyPr wrap="square" lIns="0" tIns="0" rIns="0" bIns="0" rtlCol="0" anchor="t">
+            <a:normAutofit/>
+          </a:bodyPr>
+          <a:lstStyle/>
+          <a:p>
+            <a:pPr marL="171450" indent="-171450" algn="l">
+              <a:spcAft>
+                <a:spcPts val="300"/>
+              </a:spcAft>
+              <a:buClr>
+                <a:srgbClr val="5B3BA8"/>
+              </a:buClr>
+              <a:buFont typeface="Arial"/>
+              <a:buChar char="•"/>
+            </a:pPr>
+            <a:r>
+              <a:rPr lang="en-US" sz="1050" b="1" dirty="0">
+                <a:solidFill>
+                  <a:srgbClr val="2E1B5B"/>
+                </a:solidFill>
+                <a:latin typeface="Calibri"/>
+                <a:cs typeface="Calibri"/>
+              </a:rPr>
+              <a:t xml:space="preserve">Real ibm_marrakesh: </a:t>
+            </a:r>
+            <a:r>
+              <a:rPr lang="en-US" sz="1050" dirty="0">
+                <a:solidFill>
+                  <a:srgbClr val="2E1B5B"/>
+                </a:solidFill>
+                <a:latin typeface="Calibri"/>
+                <a:cs typeface="Calibri"/>
+              </a:rPr>
+              <a:t xml:space="preserve">66 circuits, 1,024 shots, 20 s of quantum time.</a:t>
+            </a:r>
+          </a:p>
+          <a:p>
+            <a:pPr marL="171450" indent="-171450" algn="l">
+              <a:spcAft>
+                <a:spcPts val="300"/>
+              </a:spcAft>
+              <a:buClr>
+                <a:srgbClr val="5B3BA8"/>
+              </a:buClr>
+              <a:buFont typeface="Arial"/>
+              <a:buChar char="•"/>
+            </a:pPr>
+            <a:r>
+              <a:rPr lang="en-US" sz="1050" b="1" dirty="0">
+                <a:solidFill>
+                  <a:srgbClr val="2E1B5B"/>
+                </a:solidFill>
+                <a:latin typeface="Calibri"/>
+                <a:cs typeface="Calibri"/>
+              </a:rPr>
+              <a:t xml:space="preserve">Kernel error: </a:t>
+            </a:r>
+            <a:r>
+              <a:rPr lang="en-US" sz="1050" dirty="0">
+                <a:solidFill>
+                  <a:srgbClr val="2E1B5B"/>
+                </a:solidFill>
+                <a:latin typeface="Calibri"/>
+                <a:cs typeface="Calibri"/>
+              </a:rPr>
+              <a:t xml:space="preserve">17.5% on hardware vs 10.3% simulated, yet correlation with ideal is 0.996.</a:t>
+            </a:r>
+          </a:p>
+          <a:p>
+            <a:pPr marL="171450" indent="-171450" algn="l">
+              <a:spcAft>
+                <a:spcPts val="300"/>
+              </a:spcAft>
+              <a:buClr>
+                <a:srgbClr val="5B3BA8"/>
+              </a:buClr>
+              <a:buFont typeface="Arial"/>
+              <a:buChar char="•"/>
+            </a:pPr>
+            <a:r>
+              <a:rPr lang="en-US" sz="1050" b="1" dirty="0">
+                <a:solidFill>
+                  <a:srgbClr val="2E1B5B"/>
+                </a:solidFill>
+                <a:latin typeface="Calibri"/>
+                <a:cs typeface="Calibri"/>
+              </a:rPr>
+              <a:t xml:space="preserve">Why it works: </a:t>
+            </a:r>
+            <a:r>
+              <a:rPr lang="en-US" sz="1050" dirty="0">
+                <a:solidFill>
+                  <a:srgbClr val="2E1B5B"/>
+                </a:solidFill>
+                <a:latin typeface="Calibri"/>
+                <a:cs typeface="Calibri"/>
+              </a:rPr>
+              <a:t xml:space="preserve">noise shrinks all values a little, so the ranking of molecules survives.</a:t>
+            </a:r>
+          </a:p>
+          <a:p>
+            <a:pPr marL="171450" indent="-171450" algn="l">
+              <a:spcAft>
+                <a:spcPts val="300"/>
+              </a:spcAft>
+              <a:buClr>
+                <a:srgbClr val="5B3BA8"/>
+              </a:buClr>
+              <a:buFont typeface="Arial"/>
+              <a:buChar char="•"/>
+            </a:pPr>
+            <a:r>
+              <a:rPr lang="en-US" sz="1050" b="1" dirty="0">
+                <a:solidFill>
+                  <a:srgbClr val="2E1B5B"/>
+                </a:solidFill>
+                <a:latin typeface="Calibri"/>
+                <a:cs typeface="Calibri"/>
+              </a:rPr>
+              <a:t xml:space="preserve">Full cost: </a:t>
+            </a:r>
+            <a:r>
+              <a:rPr lang="en-US" sz="1050" dirty="0">
+                <a:solidFill>
+                  <a:srgbClr val="2E1B5B"/>
+                </a:solidFill>
+                <a:latin typeface="Calibri"/>
+                <a:cs typeface="Calibri"/>
+              </a:rPr>
+              <a:t xml:space="preserve">a fidelity kernel on 1,513 molecules needs 1.1 M circuits, 92.5 h of device time.</a:t>
+            </a:r>
+          </a:p>
+          <a:p>
+            <a:pPr marL="171450" indent="-171450" algn="l">
+              <a:spcAft>
+                <a:spcPts val="300"/>
+              </a:spcAft>
+              <a:buClr>
+                <a:srgbClr val="5B3BA8"/>
+              </a:buClr>
+              <a:buFont typeface="Arial"/>
+              <a:buChar char="•"/>
+            </a:pPr>
+            <a:r>
+              <a:rPr lang="en-US" sz="1050" b="1" dirty="0">
+                <a:solidFill>
+                  <a:srgbClr val="2E1B5B"/>
+                </a:solidFill>
+                <a:latin typeface="Calibri"/>
+                <a:cs typeface="Calibri"/>
+              </a:rPr>
+              <a:t xml:space="preserve">Projected kernel: </a:t>
+            </a:r>
+            <a:r>
+              <a:rPr lang="en-US" sz="1050" dirty="0">
+                <a:solidFill>
+                  <a:srgbClr val="2E1B5B"/>
+                </a:solidFill>
+                <a:latin typeface="Calibri"/>
+                <a:cs typeface="Calibri"/>
+              </a:rPr>
+              <a:t xml:space="preserve">1,513 circuits, 7.6 min, only 0.011 ROC-AUC behind.</a:t>
+            </a:r>
+          </a:p>
+        </p:txBody>
+      </p:sp>
+      <p:sp>
+        <p:nvSpPr>
+          <p:cNvPr id="25" name="Slide Number Placeholder 0"/>
+          <p:cNvSpPr>
+            <a:spLocks noGrp="1"/>
+          </p:cNvSpPr>
+          <p:nvPr>
+            <p:ph type="sldNum" sz="quarter" idx="4294967295"/>
+          </p:nvPr>
+        </p:nvSpPr>
+        <p:spPr>
+          <a:xfrm>
+            <a:off x="8321040" y="4864608"/>
+            <a:ext cx="365760" cy="274320"/>
+          </a:xfrm>
+          <a:prstGeom prst="rect">
+            <a:avLst/>
+          </a:prstGeom>
+          <a:extLst>
+            <a:ext uri="{C572A759-6A51-4108-AA02-DFA0A04FC94B}">
+              <ma14:wrappingTextBoxFlag xmlns:ma14="http://schemas.microsoft.com/office/mac/drawingml/2011/main" xmlns="" val="0"/>
+            </a:ext>
+          </a:extLst>
+        </p:spPr>
+        <p:txBody>
+          <a:bodyPr anchor="ctr"/>
+          <a:lstStyle>
+            <a:lvl1pPr>
+              <a:defRPr sz="900">
+                <a:solidFill>
+                  <a:srgbClr val="2E1B5B"/>
+                </a:solidFill>
+              </a:defRPr>
+            </a:lvl1pPr>
+          </a:lstStyle>
+          <a:p>
+            <a:pPr algn="r"/>
+            <a:fld id="{F7021451-1387-4CA6-816F-3879F97B5CBC}" type="slidenum">
+              <a:rPr lang="en-US" b="1"/>
+              <a:t>7</a:t>
+            </a:fld>
+            <a:endParaRPr lang="en-US"/>
+          </a:p>
+        </p:txBody>
+      </p:sp>
+    </p:spTree>
+  </p:cSld>
+  <p:clrMapOvr>
+    <a:masterClrMapping/>
+  </p:clrMapOvr>
+</p:sld>
+</file>
+
+<file path=ppt/slides/slide9.xml><?xml version="1.0" encoding="utf-8"?>
 <p:sld xmlns:a="http://schemas.openxmlformats.org/drawingml/2006/main" xmlns:r="http://schemas.openxmlformats.org/officeDocument/2006/relationships" xmlns:p="http://schemas.openxmlformats.org/presentationml/2006/main">
   <p:cSld name="Slide 8">
     <p:spTree>
@@ -9038,7 +10093,7 @@
                 <a:latin typeface="Calibri"/>
                 <a:cs typeface="Calibri"/>
               </a:rPr>
-              <a:t xml:space="preserve">Shows when quantum ML is worth trying for virtual screening, and when a Random Forest is still the better tool.</a:t>
+              <a:t xml:space="preserve">Guides the next assay: model-ranked picking nearly doubles hits (+85 in 250 tests).</a:t>
             </a:r>
           </a:p>
           <a:p>
@@ -9060,7 +10115,7 @@
                 <a:latin typeface="Calibri"/>
                 <a:cs typeface="Calibri"/>
               </a:rPr>
-              <a:t xml:space="preserve">Works for any target with SMILES and activity labels.</a:t>
+              <a:t xml:space="preserve">Works for any target with SMILES and activity labels; 3 datasets already in QuDock-Bench.</a:t>
             </a:r>
           </a:p>
         </p:txBody>
@@ -9130,7 +10185,7 @@
                 <a:latin typeface="Calibri"/>
                 <a:cs typeface="Calibri"/>
               </a:rPr>
-              <a:t xml:space="preserve">A fair benchmark template: same features, scaffold split, seeds, significance tests.</a:t>
+              <a:t xml:space="preserve">A fair benchmark template: same features, 6 scaffold splits, 10 seeds, significance tests.</a:t>
             </a:r>
           </a:p>
           <a:p>
@@ -9152,7 +10207,7 @@
                 <a:latin typeface="Calibri"/>
                 <a:cs typeface="Calibri"/>
               </a:rPr>
-              <a:t xml:space="preserve">Real-hardware evidence that kernel rankings survive noise.</a:t>
+              <a:t xml:space="preserve">Shows how to fight kernel concentration and what a hardware run really costs.</a:t>
             </a:r>
           </a:p>
         </p:txBody>
@@ -9222,7 +10277,7 @@
                 <a:latin typeface="Calibri"/>
                 <a:cs typeface="Calibri"/>
               </a:rPr>
-              <a:t xml:space="preserve">All code, results and a demo notebook are public.</a:t>
+              <a:t xml:space="preserve">Code, results, docs, an HTTP API and a live web app are public.</a:t>
             </a:r>
           </a:p>
           <a:p>
@@ -9244,7 +10299,7 @@
                 <a:latin typeface="Calibri"/>
                 <a:cs typeface="Calibri"/>
               </a:rPr>
-              <a:t xml:space="preserve">Runs on a laptop in minutes; the hardware run fits in 20 s of free IBM time.</a:t>
+              <a:t xml:space="preserve">182 tests; one command regenerates every number on a laptop.</a:t>
             </a:r>
           </a:p>
         </p:txBody>
@@ -9288,7 +10343,7 @@
                 <a:latin typeface="Calibri"/>
                 <a:cs typeface="Calibri"/>
               </a:rPr>
-              <a:t xml:space="preserve">An honest negative result is useful: it tells researchers where quantum kernels need to improve before they help real drug pipelines.</a:t>
+              <a:t xml:space="preserve">An honest result is useful: quantum kernels reach the classical ceiling today, and the projected design makes a real hardware run affordable.</a:t>
             </a:r>
           </a:p>
         </p:txBody>
@@ -9333,550 +10388,6 @@
             <a:fld id="{F7021451-1387-4CA6-816F-3879F97B5CBC}" type="slidenum">
               <a:rPr lang="en-US" b="1"/>
               <a:t>8</a:t>
-            </a:fld>
-            <a:endParaRPr lang="en-US"/>
-          </a:p>
-        </p:txBody>
-      </p:sp>
-    </p:spTree>
-  </p:cSld>
-  <p:clrMapOvr>
-    <a:masterClrMapping/>
-  </p:clrMapOvr>
-</p:sld>
-</file>
-
-<file path=ppt/slides/slide9.xml><?xml version="1.0" encoding="utf-8"?>
-<p:sld xmlns:a="http://schemas.openxmlformats.org/drawingml/2006/main" xmlns:r="http://schemas.openxmlformats.org/officeDocument/2006/relationships" xmlns:p="http://schemas.openxmlformats.org/presentationml/2006/main">
-  <p:cSld name="Slide 9">
-    <p:spTree>
-      <p:nvGrpSpPr>
-        <p:cNvPr id="1" name=""/>
-        <p:cNvGrpSpPr/>
-        <p:nvPr/>
-      </p:nvGrpSpPr>
-      <p:grpSpPr>
-        <a:xfrm>
-          <a:off x="0" y="0"/>
-          <a:ext cx="0" cy="0"/>
-          <a:chOff x="0" y="0"/>
-          <a:chExt cx="0" cy="0"/>
-        </a:xfrm>
-      </p:grpSpPr>
-      <p:sp>
-        <p:nvSpPr>
-          <p:cNvPr id="2" name="Text 14"/>
-          <p:cNvSpPr>
-            <a:spLocks noGrp="1"/>
-          </p:cNvSpPr>
-          <p:nvPr>
-            <p:ph type="title" idx="120" hasCustomPrompt="1"/>
-          </p:nvPr>
-        </p:nvSpPr>
-        <p:spPr>
-          <a:xfrm>
-            <a:off x="457200" y="841248"/>
-            <a:ext cx="6309360" cy="594360"/>
-          </a:xfrm>
-          <a:prstGeom prst="rect">
-            <a:avLst/>
-          </a:prstGeom>
-          <a:noFill/>
-          <a:ln/>
-        </p:spPr>
-        <p:txBody>
-          <a:bodyPr wrap="square" lIns="0" tIns="0" rIns="0" bIns="0" rtlCol="0" anchor="ctr"/>
-          <a:lstStyle/>
-          <a:p>
-            <a:pPr marL="0" indent="0" algn="l">
-              <a:buNone/>
-            </a:pPr>
-            <a:r>
-              <a:rPr lang="en-US" sz="2600" b="1" dirty="0">
-                <a:solidFill>
-                  <a:srgbClr val="2E1B5B"/>
-                </a:solidFill>
-                <a:latin typeface="Georgia" pitchFamily="34" charset="0"/>
-                <a:ea typeface="Georgia" pitchFamily="34" charset="-122"/>
-                <a:cs typeface="Georgia" pitchFamily="34" charset="-120"/>
-              </a:rPr>
-              <a:t>Challenges &amp; Future Scope</a:t>
-            </a:r>
-            <a:endParaRPr lang="en-US" sz="2600" dirty="0"/>
-          </a:p>
-        </p:txBody>
-      </p:sp>
-      <p:sp>
-        <p:nvSpPr>
-          <p:cNvPr id="3" name="Title accent"/>
-          <p:cNvSpPr/>
-          <p:nvPr/>
-        </p:nvSpPr>
-        <p:spPr>
-          <a:xfrm>
-            <a:off x="457200" y="1463040"/>
-            <a:ext cx="256032" cy="45720"/>
-          </a:xfrm>
-          <a:prstGeom prst="rect">
-            <a:avLst/>
-          </a:prstGeom>
-          <a:solidFill>
-            <a:srgbClr val="7C93F0"/>
-          </a:solidFill>
-          <a:ln w="12700">
-            <a:solidFill>
-              <a:srgbClr val="7C93F0"/>
-            </a:solidFill>
-            <a:prstDash val="solid"/>
-          </a:ln>
-        </p:spPr>
-      </p:sp>
-      <p:sp>
-        <p:nvSpPr>
-          <p:cNvPr id="4" name="Title accent"/>
-          <p:cNvSpPr/>
-          <p:nvPr/>
-        </p:nvSpPr>
-        <p:spPr>
-          <a:xfrm>
-            <a:off x="731520" y="1463040"/>
-            <a:ext cx="256032" cy="45720"/>
-          </a:xfrm>
-          <a:prstGeom prst="rect">
-            <a:avLst/>
-          </a:prstGeom>
-          <a:solidFill>
-            <a:srgbClr val="E8639F"/>
-          </a:solidFill>
-          <a:ln w="12700">
-            <a:solidFill>
-              <a:srgbClr val="E8639F"/>
-            </a:solidFill>
-            <a:prstDash val="solid"/>
-          </a:ln>
-        </p:spPr>
-      </p:sp>
-      <p:sp>
-        <p:nvSpPr>
-          <p:cNvPr id="5" name="Title accent"/>
-          <p:cNvSpPr/>
-          <p:nvPr/>
-        </p:nvSpPr>
-        <p:spPr>
-          <a:xfrm>
-            <a:off x="1005840" y="1463040"/>
-            <a:ext cx="256032" cy="45720"/>
-          </a:xfrm>
-          <a:prstGeom prst="rect">
-            <a:avLst/>
-          </a:prstGeom>
-          <a:solidFill>
-            <a:srgbClr val="5B3BA8"/>
-          </a:solidFill>
-          <a:ln w="12700">
-            <a:solidFill>
-              <a:srgbClr val="5B3BA8"/>
-            </a:solidFill>
-            <a:prstDash val="solid"/>
-          </a:ln>
-        </p:spPr>
-      </p:sp>
-      <p:sp>
-        <p:nvSpPr>
-          <p:cNvPr id="6" name="Content card"/>
-          <p:cNvSpPr/>
-          <p:nvPr/>
-        </p:nvSpPr>
-        <p:spPr>
-          <a:xfrm>
-            <a:off x="457200" y="1691640"/>
-            <a:ext cx="8229600" cy="2926080"/>
-          </a:xfrm>
-          <a:prstGeom prst="roundRect">
-            <a:avLst>
-              <a:gd name="adj" fmla="val 2500"/>
-            </a:avLst>
-          </a:prstGeom>
-          <a:solidFill>
-            <a:srgbClr val="FFFFFF"/>
-          </a:solidFill>
-          <a:ln w="9525">
-            <a:solidFill>
-              <a:srgbClr val="B8BDEB"/>
-            </a:solidFill>
-            <a:prstDash val="solid"/>
-          </a:ln>
-        </p:spPr>
-      </p:sp>
-      <p:sp>
-        <p:nvSpPr>
-          <p:cNvPr id="7" name="Card accent"/>
-          <p:cNvSpPr/>
-          <p:nvPr/>
-        </p:nvSpPr>
-        <p:spPr>
-          <a:xfrm>
-            <a:off x="685800" y="1691640"/>
-            <a:ext cx="822960" cy="54864"/>
-          </a:xfrm>
-          <a:prstGeom prst="rect">
-            <a:avLst/>
-          </a:prstGeom>
-          <a:solidFill>
-            <a:srgbClr val="E8639F"/>
-          </a:solidFill>
-          <a:ln w="12700">
-            <a:solidFill>
-              <a:srgbClr val="E8639F"/>
-            </a:solidFill>
-            <a:prstDash val="solid"/>
-          </a:ln>
-        </p:spPr>
-      </p:sp>
-      <p:sp>
-        <p:nvSpPr>
-          <p:cNvPr id="143" name="Challenges"/>
-          <p:cNvSpPr txBox="1"/>
-          <p:nvPr/>
-        </p:nvSpPr>
-        <p:spPr>
-          <a:xfrm>
-            <a:off x="685800" y="1828800"/>
-            <a:ext cx="4023360" cy="2697480"/>
-          </a:xfrm>
-          <a:prstGeom prst="rect">
-            <a:avLst/>
-          </a:prstGeom>
-          <a:noFill/>
-          <a:ln>
-            <a:noFill/>
-          </a:ln>
-        </p:spPr>
-        <p:txBody>
-          <a:bodyPr wrap="square" lIns="0" tIns="0" rIns="0" bIns="0" rtlCol="0" anchor="t">
-            <a:normAutofit/>
-          </a:bodyPr>
-          <a:lstStyle/>
-          <a:p>
-            <a:pPr marL="0" indent="0" algn="l">
-              <a:spcAft>
-                <a:spcPts val="400"/>
-              </a:spcAft>
-              <a:buNone/>
-            </a:pPr>
-            <a:r>
-              <a:rPr lang="en-US" sz="1200" b="1" dirty="0">
-                <a:solidFill>
-                  <a:srgbClr val="5B3BA8"/>
-                </a:solidFill>
-                <a:latin typeface="Calibri"/>
-                <a:cs typeface="Calibri"/>
-              </a:rPr>
-              <a:t xml:space="preserve">CHALLENGES WE HIT</a:t>
-            </a:r>
-          </a:p>
-          <a:p>
-            <a:pPr marL="171450" indent="-171450" algn="l">
-              <a:spcAft>
-                <a:spcPts val="400"/>
-              </a:spcAft>
-              <a:buClr>
-                <a:srgbClr val="5B3BA8"/>
-              </a:buClr>
-              <a:buFont typeface="Arial"/>
-              <a:buChar char="•"/>
-            </a:pPr>
-            <a:r>
-              <a:rPr lang="en-US" sz="1050" b="1" dirty="0">
-                <a:solidFill>
-                  <a:srgbClr val="2E1B5B"/>
-                </a:solidFill>
-                <a:latin typeface="Calibri"/>
-                <a:cs typeface="Calibri"/>
-              </a:rPr>
-              <a:t xml:space="preserve">Crashes on Linux: </a:t>
-            </a:r>
-            <a:r>
-              <a:rPr lang="en-US" sz="1050" dirty="0">
-                <a:solidFill>
-                  <a:srgbClr val="2E1B5B"/>
-                </a:solidFill>
-                <a:latin typeface="Calibri"/>
-                <a:cs typeface="Calibri"/>
-              </a:rPr>
-              <a:t xml:space="preserve">Qiskit Aer and the Rust transpiler ran out of TLS and stack; fixed with GLIBC_TUNABLES and RUST_MIN_STACK in CI and Docker.</a:t>
-            </a:r>
-          </a:p>
-          <a:p>
-            <a:pPr marL="171450" indent="-171450" algn="l">
-              <a:spcAft>
-                <a:spcPts val="400"/>
-              </a:spcAft>
-              <a:buClr>
-                <a:srgbClr val="5B3BA8"/>
-              </a:buClr>
-              <a:buFont typeface="Arial"/>
-              <a:buChar char="•"/>
-            </a:pPr>
-            <a:r>
-              <a:rPr lang="en-US" sz="1050" b="1" dirty="0">
-                <a:solidFill>
-                  <a:srgbClr val="2E1B5B"/>
-                </a:solidFill>
-                <a:latin typeface="Calibri"/>
-                <a:cs typeface="Calibri"/>
-              </a:rPr>
-              <a:t xml:space="preserve">Wrong noise numbers: </a:t>
-            </a:r>
-            <a:r>
-              <a:rPr lang="en-US" sz="1050" dirty="0">
-                <a:solidFill>
-                  <a:srgbClr val="2E1B5B"/>
-                </a:solidFill>
-                <a:latin typeface="Calibri"/>
-                <a:cs typeface="Calibri"/>
-              </a:rPr>
-              <a:t xml:space="preserve">our first study used a poor qubit layout (25 to 28% error); the real device exposed it, and a corrected run gives 8 to 13%.</a:t>
-            </a:r>
-          </a:p>
-          <a:p>
-            <a:pPr marL="171450" indent="-171450" algn="l">
-              <a:spcAft>
-                <a:spcPts val="400"/>
-              </a:spcAft>
-              <a:buClr>
-                <a:srgbClr val="5B3BA8"/>
-              </a:buClr>
-              <a:buFont typeface="Arial"/>
-              <a:buChar char="•"/>
-            </a:pPr>
-            <a:r>
-              <a:rPr lang="en-US" sz="1050" b="1" dirty="0">
-                <a:solidFill>
-                  <a:srgbClr val="2E1B5B"/>
-                </a:solidFill>
-                <a:latin typeface="Calibri"/>
-                <a:cs typeface="Calibri"/>
-              </a:rPr>
-              <a:t xml:space="preserve">Limited quantum time: </a:t>
-            </a:r>
-            <a:r>
-              <a:rPr lang="en-US" sz="1050" dirty="0">
-                <a:solidFill>
-                  <a:srgbClr val="2E1B5B"/>
-                </a:solidFill>
-                <a:latin typeface="Calibri"/>
-                <a:cs typeface="Calibri"/>
-              </a:rPr>
-              <a:t xml:space="preserve">free plan minutes, so the hardware run uses 12 molecules in one job.</a:t>
-            </a:r>
-          </a:p>
-          <a:p>
-            <a:pPr marL="171450" indent="-171450" algn="l">
-              <a:spcAft>
-                <a:spcPts val="400"/>
-              </a:spcAft>
-              <a:buClr>
-                <a:srgbClr val="5B3BA8"/>
-              </a:buClr>
-              <a:buFont typeface="Arial"/>
-              <a:buChar char="•"/>
-            </a:pPr>
-            <a:r>
-              <a:rPr lang="en-US" sz="1050" b="1" dirty="0">
-                <a:solidFill>
-                  <a:srgbClr val="2E1B5B"/>
-                </a:solidFill>
-                <a:latin typeface="Calibri"/>
-                <a:cs typeface="Calibri"/>
-              </a:rPr>
-              <a:t xml:space="preserve">Kernel concentration: </a:t>
-            </a:r>
-            <a:r>
-              <a:rPr lang="en-US" sz="1050" dirty="0">
-                <a:solidFill>
-                  <a:srgbClr val="2E1B5B"/>
-                </a:solidFill>
-                <a:latin typeface="Calibri"/>
-                <a:cs typeface="Calibri"/>
-              </a:rPr>
-              <a:t xml:space="preserve">values bunch together as qubits grow.</a:t>
-            </a:r>
-          </a:p>
-        </p:txBody>
-      </p:sp>
-      <p:sp>
-        <p:nvSpPr>
-          <p:cNvPr id="144" name="Future"/>
-          <p:cNvSpPr txBox="1"/>
-          <p:nvPr/>
-        </p:nvSpPr>
-        <p:spPr>
-          <a:xfrm>
-            <a:off x="4892040" y="1828800"/>
-            <a:ext cx="3566160" cy="2697480"/>
-          </a:xfrm>
-          <a:prstGeom prst="rect">
-            <a:avLst/>
-          </a:prstGeom>
-          <a:noFill/>
-          <a:ln>
-            <a:noFill/>
-          </a:ln>
-        </p:spPr>
-        <p:txBody>
-          <a:bodyPr wrap="square" lIns="0" tIns="0" rIns="0" bIns="0" rtlCol="0" anchor="t">
-            <a:normAutofit/>
-          </a:bodyPr>
-          <a:lstStyle/>
-          <a:p>
-            <a:pPr marL="0" indent="0" algn="l">
-              <a:spcAft>
-                <a:spcPts val="400"/>
-              </a:spcAft>
-              <a:buNone/>
-            </a:pPr>
-            <a:r>
-              <a:rPr lang="en-US" sz="1200" b="1" dirty="0">
-                <a:solidFill>
-                  <a:srgbClr val="E8639F"/>
-                </a:solidFill>
-                <a:latin typeface="Calibri"/>
-                <a:cs typeface="Calibri"/>
-              </a:rPr>
-              <a:t xml:space="preserve">FUTURE SCOPE</a:t>
-            </a:r>
-          </a:p>
-          <a:p>
-            <a:pPr marL="171450" indent="-171450" algn="l">
-              <a:spcAft>
-                <a:spcPts val="500"/>
-              </a:spcAft>
-              <a:buClr>
-                <a:srgbClr val="E8639F"/>
-              </a:buClr>
-              <a:buFont typeface="Arial"/>
-              <a:buChar char="•"/>
-            </a:pPr>
-            <a:r>
-              <a:rPr lang="en-US" sz="1150" dirty="0">
-                <a:solidFill>
-                  <a:srgbClr val="2E1B5B"/>
-                </a:solidFill>
-                <a:latin typeface="Calibri"/>
-                <a:cs typeface="Calibri"/>
-              </a:rPr>
-              <a:t xml:space="preserve">Trainable and projected quantum kernels to fight concentration.</a:t>
-            </a:r>
-          </a:p>
-          <a:p>
-            <a:pPr marL="171450" indent="-171450" algn="l">
-              <a:spcAft>
-                <a:spcPts val="500"/>
-              </a:spcAft>
-              <a:buClr>
-                <a:srgbClr val="E8639F"/>
-              </a:buClr>
-              <a:buFont typeface="Arial"/>
-              <a:buChar char="•"/>
-            </a:pPr>
-            <a:r>
-              <a:rPr lang="en-US" sz="1150" dirty="0">
-                <a:solidFill>
-                  <a:srgbClr val="2E1B5B"/>
-                </a:solidFill>
-                <a:latin typeface="Calibri"/>
-                <a:cs typeface="Calibri"/>
-              </a:rPr>
-              <a:t xml:space="preserve">Error mitigation (readout, ZNE) and a full QSVC trained on hardware kernels.</a:t>
-            </a:r>
-          </a:p>
-          <a:p>
-            <a:pPr marL="171450" indent="-171450" algn="l">
-              <a:spcAft>
-                <a:spcPts val="500"/>
-              </a:spcAft>
-              <a:buClr>
-                <a:srgbClr val="E8639F"/>
-              </a:buClr>
-              <a:buFont typeface="Arial"/>
-              <a:buChar char="•"/>
-            </a:pPr>
-            <a:r>
-              <a:rPr lang="en-US" sz="1150" dirty="0">
-                <a:solidFill>
-                  <a:srgbClr val="2E1B5B"/>
-                </a:solidFill>
-                <a:latin typeface="Calibri"/>
-                <a:cs typeface="Calibri"/>
-              </a:rPr>
-              <a:t xml:space="preserve">More targets from MoleculeNet and richer molecular features.</a:t>
-            </a:r>
-          </a:p>
-          <a:p>
-            <a:pPr marL="171450" indent="-171450" algn="l">
-              <a:spcAft>
-                <a:spcPts val="500"/>
-              </a:spcAft>
-              <a:buClr>
-                <a:srgbClr val="E8639F"/>
-              </a:buClr>
-              <a:buFont typeface="Arial"/>
-              <a:buChar char="•"/>
-            </a:pPr>
-            <a:r>
-              <a:rPr lang="en-US" sz="1150" dirty="0">
-                <a:solidFill>
-                  <a:srgbClr val="2E1B5B"/>
-                </a:solidFill>
-                <a:latin typeface="Calibri"/>
-                <a:cs typeface="Calibri"/>
-              </a:rPr>
-              <a:t xml:space="preserve">More seeds and molecules for statistically significant comparisons.</a:t>
-            </a:r>
-          </a:p>
-        </p:txBody>
-      </p:sp>
-      <p:sp>
-        <p:nvSpPr>
-          <p:cNvPr id="25" name="Slide Number Placeholder 0"/>
-          <p:cNvSpPr>
-            <a:spLocks noGrp="1"/>
-          </p:cNvSpPr>
-          <p:nvPr>
-            <p:ph type="sldNum" sz="quarter" idx="4294967295"/>
-          </p:nvPr>
-        </p:nvSpPr>
-        <p:spPr>
-          <a:xfrm>
-            <a:off x="8321040" y="4864608"/>
-            <a:ext cx="365760" cy="274320"/>
-          </a:xfrm>
-          <a:prstGeom prst="rect">
-            <a:avLst/>
-          </a:prstGeom>
-          <a:extLst>
-            <a:ext uri="{C572A759-6A51-4108-AA02-DFA0A04FC94B}">
-              <ma14:wrappingTextBoxFlag xmlns:ma14="http://schemas.microsoft.com/office/mac/drawingml/2011/main" xmlns="" val="0"/>
-            </a:ext>
-          </a:extLst>
-        </p:spPr>
-        <p:txBody>
-          <a:bodyPr anchor="ctr"/>
-          <a:lstStyle>
-            <a:lvl1pPr>
-              <a:defRPr sz="900">
-                <a:solidFill>
-                  <a:srgbClr val="2E1B5B"/>
-                </a:solidFill>
-              </a:defRPr>
-            </a:lvl1pPr>
-          </a:lstStyle>
-          <a:p>
-            <a:pPr algn="r"/>
-            <a:fld id="{F7021451-1387-4CA6-816F-3879F97B5CBC}" type="slidenum">
-              <a:rPr lang="en-US" b="1"/>
-              <a:t>9</a:t>
             </a:fld>
             <a:endParaRPr lang="en-US"/>
           </a:p>

</xml_diff>